<commit_message>
Bootstrap MT25 business-plan-coto de punta a punta + fixes de pptx compartido
Agrega el entregable completo de MT25 (research citado, plans revisados,
business-plan-coto.md, presentacion.html y business-plan-coto.pptx),
el prototipo React compartido prototipo-wallet-coto/ para la demo de
MT10/MT25, dos skills nuevas de research (moats/network effects,
market sizing), y memoria de agentes actualizada.

En design-system/components/pptx_kit.py: corrige dos bugs reales
encontrados auditando el pptx en Keynote — buffers insuficientes entre
bloques de altura dinámica (bullets/roadmap/callout) que causaban
overlap visual, y un bug de python-pptx donde agregar notas del orador
(notes_slide) omite <p:notesMasterIdLst> en presentation.xml, lo que
hace que Keynote rechace el archivo entero como formato inválido
aunque PowerPoint lo tolere. Aplica también el mismo fix de buffer al
pptx de mt10.

Co-Authored-By: Claude Sonnet 5 <noreply@anthropic.com>
</commit_message>
<xml_diff>
--- a/materias/mt10-innovacion-tecnologica/fidelizacion-coto/entregable/presentacion/plataforma-fidelizacion-coto.pptx
+++ b/materias/mt10-innovacion-tecnologica/fidelizacion-coto/entregable/presentacion/plataforma-fidelizacion-coto.pptx
@@ -15254,7 +15254,7 @@
         </p:nvSpPr>
         <p:spPr>
           <a:xfrm>
-            <a:off x="548640" y="457200"/>
+            <a:off x="548640" y="786384"/>
             <a:ext cx="2084831" cy="384048"/>
           </a:xfrm>
           <a:prstGeom prst="roundRect">
@@ -15309,7 +15309,7 @@
         </p:nvSpPr>
         <p:spPr>
           <a:xfrm>
-            <a:off x="2743199" y="457200"/>
+            <a:off x="2743199" y="786384"/>
             <a:ext cx="2084831" cy="384048"/>
           </a:xfrm>
           <a:prstGeom prst="roundRect">
@@ -15364,7 +15364,7 @@
         </p:nvSpPr>
         <p:spPr>
           <a:xfrm>
-            <a:off x="4937758" y="457200"/>
+            <a:off x="4937758" y="786384"/>
             <a:ext cx="2084831" cy="384048"/>
           </a:xfrm>
           <a:prstGeom prst="roundRect">
@@ -15419,7 +15419,7 @@
         </p:nvSpPr>
         <p:spPr>
           <a:xfrm>
-            <a:off x="7132317" y="457200"/>
+            <a:off x="7132317" y="786384"/>
             <a:ext cx="2084831" cy="384048"/>
           </a:xfrm>
           <a:prstGeom prst="roundRect">
@@ -15474,7 +15474,7 @@
         </p:nvSpPr>
         <p:spPr>
           <a:xfrm>
-            <a:off x="9326876" y="457200"/>
+            <a:off x="9326876" y="786384"/>
             <a:ext cx="2084831" cy="384048"/>
           </a:xfrm>
           <a:prstGeom prst="roundRect">
@@ -15948,7 +15948,7 @@
         </p:nvSpPr>
         <p:spPr>
           <a:xfrm>
-            <a:off x="548640" y="457200"/>
+            <a:off x="548640" y="786384"/>
             <a:ext cx="2084831" cy="384048"/>
           </a:xfrm>
           <a:prstGeom prst="roundRect">
@@ -16003,7 +16003,7 @@
         </p:nvSpPr>
         <p:spPr>
           <a:xfrm>
-            <a:off x="2743199" y="457200"/>
+            <a:off x="2743199" y="786384"/>
             <a:ext cx="2084831" cy="384048"/>
           </a:xfrm>
           <a:prstGeom prst="roundRect">
@@ -16058,7 +16058,7 @@
         </p:nvSpPr>
         <p:spPr>
           <a:xfrm>
-            <a:off x="4937758" y="457200"/>
+            <a:off x="4937758" y="786384"/>
             <a:ext cx="2084831" cy="384048"/>
           </a:xfrm>
           <a:prstGeom prst="roundRect">
@@ -16113,7 +16113,7 @@
         </p:nvSpPr>
         <p:spPr>
           <a:xfrm>
-            <a:off x="7132317" y="457200"/>
+            <a:off x="7132317" y="786384"/>
             <a:ext cx="2084831" cy="384048"/>
           </a:xfrm>
           <a:prstGeom prst="roundRect">
@@ -16168,7 +16168,7 @@
         </p:nvSpPr>
         <p:spPr>
           <a:xfrm>
-            <a:off x="9326876" y="457200"/>
+            <a:off x="9326876" y="786384"/>
             <a:ext cx="2084831" cy="384048"/>
           </a:xfrm>
           <a:prstGeom prst="roundRect">
@@ -16626,7 +16626,7 @@
         </p:nvSpPr>
         <p:spPr>
           <a:xfrm>
-            <a:off x="548640" y="457200"/>
+            <a:off x="548640" y="786384"/>
             <a:ext cx="2084831" cy="384048"/>
           </a:xfrm>
           <a:prstGeom prst="roundRect">
@@ -16681,7 +16681,7 @@
         </p:nvSpPr>
         <p:spPr>
           <a:xfrm>
-            <a:off x="2743199" y="457200"/>
+            <a:off x="2743199" y="786384"/>
             <a:ext cx="2084831" cy="384048"/>
           </a:xfrm>
           <a:prstGeom prst="roundRect">
@@ -16736,7 +16736,7 @@
         </p:nvSpPr>
         <p:spPr>
           <a:xfrm>
-            <a:off x="4937758" y="457200"/>
+            <a:off x="4937758" y="786384"/>
             <a:ext cx="2084831" cy="384048"/>
           </a:xfrm>
           <a:prstGeom prst="roundRect">
@@ -16791,7 +16791,7 @@
         </p:nvSpPr>
         <p:spPr>
           <a:xfrm>
-            <a:off x="7132317" y="457200"/>
+            <a:off x="7132317" y="786384"/>
             <a:ext cx="2084831" cy="384048"/>
           </a:xfrm>
           <a:prstGeom prst="roundRect">
@@ -16846,7 +16846,7 @@
         </p:nvSpPr>
         <p:spPr>
           <a:xfrm>
-            <a:off x="9326876" y="457200"/>
+            <a:off x="9326876" y="786384"/>
             <a:ext cx="2084831" cy="384048"/>
           </a:xfrm>
           <a:prstGeom prst="roundRect">
@@ -17304,7 +17304,7 @@
         </p:nvSpPr>
         <p:spPr>
           <a:xfrm>
-            <a:off x="548640" y="457200"/>
+            <a:off x="548640" y="786384"/>
             <a:ext cx="2084831" cy="384048"/>
           </a:xfrm>
           <a:prstGeom prst="roundRect">
@@ -17359,7 +17359,7 @@
         </p:nvSpPr>
         <p:spPr>
           <a:xfrm>
-            <a:off x="2743199" y="457200"/>
+            <a:off x="2743199" y="786384"/>
             <a:ext cx="2084831" cy="384048"/>
           </a:xfrm>
           <a:prstGeom prst="roundRect">
@@ -17414,7 +17414,7 @@
         </p:nvSpPr>
         <p:spPr>
           <a:xfrm>
-            <a:off x="4937758" y="457200"/>
+            <a:off x="4937758" y="786384"/>
             <a:ext cx="2084831" cy="384048"/>
           </a:xfrm>
           <a:prstGeom prst="roundRect">
@@ -17469,7 +17469,7 @@
         </p:nvSpPr>
         <p:spPr>
           <a:xfrm>
-            <a:off x="7132317" y="457200"/>
+            <a:off x="7132317" y="786384"/>
             <a:ext cx="2084831" cy="384048"/>
           </a:xfrm>
           <a:prstGeom prst="roundRect">
@@ -17524,7 +17524,7 @@
         </p:nvSpPr>
         <p:spPr>
           <a:xfrm>
-            <a:off x="9326876" y="457200"/>
+            <a:off x="9326876" y="786384"/>
             <a:ext cx="2084831" cy="384048"/>
           </a:xfrm>
           <a:prstGeom prst="roundRect">
@@ -17998,7 +17998,7 @@
         </p:nvSpPr>
         <p:spPr>
           <a:xfrm>
-            <a:off x="548640" y="457200"/>
+            <a:off x="548640" y="786384"/>
             <a:ext cx="2084831" cy="384048"/>
           </a:xfrm>
           <a:prstGeom prst="roundRect">
@@ -18053,7 +18053,7 @@
         </p:nvSpPr>
         <p:spPr>
           <a:xfrm>
-            <a:off x="2743199" y="457200"/>
+            <a:off x="2743199" y="786384"/>
             <a:ext cx="2084831" cy="384048"/>
           </a:xfrm>
           <a:prstGeom prst="roundRect">
@@ -18108,7 +18108,7 @@
         </p:nvSpPr>
         <p:spPr>
           <a:xfrm>
-            <a:off x="4937758" y="457200"/>
+            <a:off x="4937758" y="786384"/>
             <a:ext cx="2084831" cy="384048"/>
           </a:xfrm>
           <a:prstGeom prst="roundRect">
@@ -18163,7 +18163,7 @@
         </p:nvSpPr>
         <p:spPr>
           <a:xfrm>
-            <a:off x="7132317" y="457200"/>
+            <a:off x="7132317" y="786384"/>
             <a:ext cx="2084831" cy="384048"/>
           </a:xfrm>
           <a:prstGeom prst="roundRect">
@@ -18218,7 +18218,7 @@
         </p:nvSpPr>
         <p:spPr>
           <a:xfrm>
-            <a:off x="9326876" y="457200"/>
+            <a:off x="9326876" y="786384"/>
             <a:ext cx="2084831" cy="384048"/>
           </a:xfrm>
           <a:prstGeom prst="roundRect">

</xml_diff>